<commit_message>
Update a minor changes in slide as per madam said
</commit_message>
<xml_diff>
--- a/Doc/Academic/Proposal/Slide_Proposal_Defence_finalized.pptx
+++ b/Doc/Academic/Proposal/Slide_Proposal_Defence_finalized.pptx
@@ -272,7 +272,7 @@
           <a:p>
             <a:fld id="{D1D1EADE-8E88-4C7C-8AC5-FB148DE4940E}" type="datetime1">
               <a:rPr lang="en-US" smtClean="0"/>
-              <a:t>12/20/2025</a:t>
+              <a:t>12/23/2025</a:t>
             </a:fld>
             <a:endParaRPr lang="en-US"/>
           </a:p>
@@ -472,7 +472,7 @@
           <a:p>
             <a:fld id="{EC3C8B9C-477D-492A-96AD-1FC2CC997A73}" type="datetime1">
               <a:rPr lang="en-US" smtClean="0"/>
-              <a:t>12/20/2025</a:t>
+              <a:t>12/23/2025</a:t>
             </a:fld>
             <a:endParaRPr lang="en-US"/>
           </a:p>
@@ -682,7 +682,7 @@
           <a:p>
             <a:fld id="{42D3AED5-E26D-4E29-B1B3-7847B6779594}" type="datetime1">
               <a:rPr lang="en-US" smtClean="0"/>
-              <a:t>12/20/2025</a:t>
+              <a:t>12/23/2025</a:t>
             </a:fld>
             <a:endParaRPr lang="en-US"/>
           </a:p>
@@ -882,7 +882,7 @@
           <a:p>
             <a:fld id="{157B6794-849E-4626-908B-D15793550EFB}" type="datetime1">
               <a:rPr lang="en-US" smtClean="0"/>
-              <a:t>12/20/2025</a:t>
+              <a:t>12/23/2025</a:t>
             </a:fld>
             <a:endParaRPr lang="en-US"/>
           </a:p>
@@ -1158,7 +1158,7 @@
           <a:p>
             <a:fld id="{63DB64E7-5594-42A3-ADBF-E95A7ACEAD64}" type="datetime1">
               <a:rPr lang="en-US" smtClean="0"/>
-              <a:t>12/20/2025</a:t>
+              <a:t>12/23/2025</a:t>
             </a:fld>
             <a:endParaRPr lang="en-US"/>
           </a:p>
@@ -1431,7 +1431,7 @@
           <a:p>
             <a:fld id="{18462B0B-D248-4FFB-8695-AD7FA4B1284A}" type="datetime1">
               <a:rPr lang="en-US" smtClean="0"/>
-              <a:t>12/20/2025</a:t>
+              <a:t>12/23/2025</a:t>
             </a:fld>
             <a:endParaRPr lang="en-US"/>
           </a:p>
@@ -1854,7 +1854,7 @@
           <a:p>
             <a:fld id="{D0378EFB-9159-4510-B73F-4F0409ADE937}" type="datetime1">
               <a:rPr lang="en-US" smtClean="0"/>
-              <a:t>12/20/2025</a:t>
+              <a:t>12/23/2025</a:t>
             </a:fld>
             <a:endParaRPr lang="en-US"/>
           </a:p>
@@ -1996,7 +1996,7 @@
           <a:p>
             <a:fld id="{89BC9412-2452-4BED-A324-9D8C115361AD}" type="datetime1">
               <a:rPr lang="en-US" smtClean="0"/>
-              <a:t>12/20/2025</a:t>
+              <a:t>12/23/2025</a:t>
             </a:fld>
             <a:endParaRPr lang="en-US"/>
           </a:p>
@@ -2109,7 +2109,7 @@
           <a:p>
             <a:fld id="{F5318F62-D251-40E8-A23C-F4CFE9FEAB41}" type="datetime1">
               <a:rPr lang="en-US" smtClean="0"/>
-              <a:t>12/20/2025</a:t>
+              <a:t>12/23/2025</a:t>
             </a:fld>
             <a:endParaRPr lang="en-US"/>
           </a:p>
@@ -2422,7 +2422,7 @@
           <a:p>
             <a:fld id="{44F76144-149E-4874-93A5-554A0357CF82}" type="datetime1">
               <a:rPr lang="en-US" smtClean="0"/>
-              <a:t>12/20/2025</a:t>
+              <a:t>12/23/2025</a:t>
             </a:fld>
             <a:endParaRPr lang="en-US"/>
           </a:p>
@@ -2715,7 +2715,7 @@
           <a:p>
             <a:fld id="{50BA65D8-0540-4835-AE5C-25D29DBA01BE}" type="datetime1">
               <a:rPr lang="en-US" smtClean="0"/>
-              <a:t>12/20/2025</a:t>
+              <a:t>12/23/2025</a:t>
             </a:fld>
             <a:endParaRPr lang="en-US"/>
           </a:p>
@@ -2957,7 +2957,7 @@
           <a:p>
             <a:fld id="{E31BA835-12AC-4E8F-955A-EA3F4DE2791F}" type="datetime1">
               <a:rPr lang="en-US" smtClean="0"/>
-              <a:t>12/20/2025</a:t>
+              <a:t>12/23/2025</a:t>
             </a:fld>
             <a:endParaRPr lang="en-US"/>
           </a:p>
@@ -4009,10 +4009,10 @@
       </p:sp>
       <p:pic>
         <p:nvPicPr>
-          <p:cNvPr id="3" name="Picture 2" descr="A screenshot of a computer&#10;&#10;AI-generated content may be incorrect.">
-            <a:extLst>
-              <a:ext uri="{FF2B5EF4-FFF2-40B4-BE49-F238E27FC236}">
-                <a16:creationId xmlns:a16="http://schemas.microsoft.com/office/drawing/2014/main" id="{AE46E02A-55A6-7509-1F29-5BD3F4B094D3}"/>
+          <p:cNvPr id="4" name="Picture 3" descr="A screenshot of a computer&#10;&#10;AI-generated content may be incorrect.">
+            <a:extLst>
+              <a:ext uri="{FF2B5EF4-FFF2-40B4-BE49-F238E27FC236}">
+                <a16:creationId xmlns:a16="http://schemas.microsoft.com/office/drawing/2014/main" id="{22C8421D-EA16-74E0-7861-22261721B760}"/>
               </a:ext>
             </a:extLst>
           </p:cNvPr>
@@ -5026,13 +5026,13 @@
   <p:clrMapOvr>
     <a:masterClrMapping/>
   </p:clrMapOvr>
-  <mc:AlternateContent xmlns:mc="http://schemas.openxmlformats.org/markup-compatibility/2006">
-    <mc:Choice xmlns:p14="http://schemas.microsoft.com/office/powerpoint/2010/main" Requires="p14">
+  <mc:AlternateContent xmlns:mc="http://schemas.openxmlformats.org/markup-compatibility/2006" xmlns:p14="http://schemas.microsoft.com/office/powerpoint/2010/main">
+    <mc:Choice Requires="p14">
       <p:transition spd="med" p14:dur="700">
         <p:fade/>
       </p:transition>
     </mc:Choice>
-    <mc:Fallback>
+    <mc:Fallback xmlns="">
       <p:transition spd="med">
         <p:fade/>
       </p:transition>
@@ -5308,12 +5308,51 @@
           </a:p>
         </p:txBody>
       </p:sp>
+      <p:sp>
+        <p:nvSpPr>
+          <p:cNvPr id="4" name="TextBox 3">
+            <a:extLst>
+              <a:ext uri="{FF2B5EF4-FFF2-40B4-BE49-F238E27FC236}">
+                <a16:creationId xmlns:a16="http://schemas.microsoft.com/office/drawing/2014/main" id="{A36CBDBD-4399-DA04-8A94-5CE19502AF6E}"/>
+              </a:ext>
+            </a:extLst>
+          </p:cNvPr>
+          <p:cNvSpPr txBox="1"/>
+          <p:nvPr/>
+        </p:nvSpPr>
+        <p:spPr>
+          <a:xfrm>
+            <a:off x="0" y="113122"/>
+            <a:ext cx="4119513" cy="461665"/>
+          </a:xfrm>
+          <a:prstGeom prst="rect">
+            <a:avLst/>
+          </a:prstGeom>
+          <a:noFill/>
+        </p:spPr>
+        <p:txBody>
+          <a:bodyPr wrap="square" rtlCol="0">
+            <a:spAutoFit/>
+          </a:bodyPr>
+          <a:lstStyle/>
+          <a:p>
+            <a:r>
+              <a:rPr lang="en-US" sz="2400" b="1" dirty="0">
+                <a:solidFill>
+                  <a:schemeClr val="bg1"/>
+                </a:solidFill>
+              </a:rPr>
+              <a:t>LITERATURE REVIEW</a:t>
+            </a:r>
+          </a:p>
+        </p:txBody>
+      </p:sp>
       <p:pic>
         <p:nvPicPr>
-          <p:cNvPr id="3" name="Picture 2" descr="A screenshot of a computer">
-            <a:extLst>
-              <a:ext uri="{FF2B5EF4-FFF2-40B4-BE49-F238E27FC236}">
-                <a16:creationId xmlns:a16="http://schemas.microsoft.com/office/drawing/2014/main" id="{7ABF2BF9-F4C6-A58E-0AE0-8B26D254D601}"/>
+          <p:cNvPr id="5" name="Picture 4" descr="A screenshot of a computer">
+            <a:extLst>
+              <a:ext uri="{FF2B5EF4-FFF2-40B4-BE49-F238E27FC236}">
+                <a16:creationId xmlns:a16="http://schemas.microsoft.com/office/drawing/2014/main" id="{2CB815B8-D366-4B4B-036B-8B6283489F10}"/>
               </a:ext>
             </a:extLst>
           </p:cNvPr>
@@ -5330,8 +5369,8 @@
         </p:blipFill>
         <p:spPr>
           <a:xfrm>
-            <a:off x="0" y="1390"/>
-            <a:ext cx="12192000" cy="6855220"/>
+            <a:off x="0" y="4566"/>
+            <a:ext cx="12192000" cy="6848867"/>
           </a:xfrm>
           <a:prstGeom prst="rect">
             <a:avLst/>
@@ -5340,10 +5379,10 @@
       </p:pic>
       <p:sp>
         <p:nvSpPr>
-          <p:cNvPr id="4" name="TextBox 3">
-            <a:extLst>
-              <a:ext uri="{FF2B5EF4-FFF2-40B4-BE49-F238E27FC236}">
-                <a16:creationId xmlns:a16="http://schemas.microsoft.com/office/drawing/2014/main" id="{A36CBDBD-4399-DA04-8A94-5CE19502AF6E}"/>
+          <p:cNvPr id="6" name="TextBox 5">
+            <a:extLst>
+              <a:ext uri="{FF2B5EF4-FFF2-40B4-BE49-F238E27FC236}">
+                <a16:creationId xmlns:a16="http://schemas.microsoft.com/office/drawing/2014/main" id="{7E402DF2-918E-ED6F-CAC6-F93E49DBBFEA}"/>
               </a:ext>
             </a:extLst>
           </p:cNvPr>
@@ -5352,7 +5391,7 @@
         </p:nvSpPr>
         <p:spPr>
           <a:xfrm>
-            <a:off x="0" y="113122"/>
+            <a:off x="152400" y="265522"/>
             <a:ext cx="4119513" cy="461665"/>
           </a:xfrm>
           <a:prstGeom prst="rect">
@@ -5387,13 +5426,13 @@
   <p:clrMapOvr>
     <a:masterClrMapping/>
   </p:clrMapOvr>
-  <mc:AlternateContent xmlns:mc="http://schemas.openxmlformats.org/markup-compatibility/2006">
-    <mc:Choice xmlns:p159="http://schemas.microsoft.com/office/powerpoint/2015/09/main" Requires="p159">
+  <mc:AlternateContent xmlns:mc="http://schemas.openxmlformats.org/markup-compatibility/2006" xmlns:p159="http://schemas.microsoft.com/office/powerpoint/2015/09/main">
+    <mc:Choice Requires="p159">
       <p:transition xmlns:p14="http://schemas.microsoft.com/office/powerpoint/2010/main" spd="slow" p14:dur="2000">
         <p159:morph option="byObject"/>
       </p:transition>
     </mc:Choice>
-    <mc:Fallback>
+    <mc:Fallback xmlns="">
       <p:transition spd="slow">
         <p:fade/>
       </p:transition>
@@ -5748,13 +5787,13 @@
   <p:clrMapOvr>
     <a:masterClrMapping/>
   </p:clrMapOvr>
-  <mc:AlternateContent xmlns:mc="http://schemas.openxmlformats.org/markup-compatibility/2006">
-    <mc:Choice xmlns:p14="http://schemas.microsoft.com/office/powerpoint/2010/main" Requires="p14">
+  <mc:AlternateContent xmlns:mc="http://schemas.openxmlformats.org/markup-compatibility/2006" xmlns:p14="http://schemas.microsoft.com/office/powerpoint/2010/main">
+    <mc:Choice Requires="p14">
       <p:transition spd="slow" p14:dur="1500">
         <p:split orient="vert"/>
       </p:transition>
     </mc:Choice>
-    <mc:Fallback>
+    <mc:Fallback xmlns="">
       <p:transition spd="slow">
         <p:split orient="vert"/>
       </p:transition>
@@ -6079,13 +6118,13 @@
   <p:clrMapOvr>
     <a:masterClrMapping/>
   </p:clrMapOvr>
-  <mc:AlternateContent xmlns:mc="http://schemas.openxmlformats.org/markup-compatibility/2006">
-    <mc:Choice xmlns:p14="http://schemas.microsoft.com/office/powerpoint/2010/main" Requires="p14">
+  <mc:AlternateContent xmlns:mc="http://schemas.openxmlformats.org/markup-compatibility/2006" xmlns:p14="http://schemas.microsoft.com/office/powerpoint/2010/main">
+    <mc:Choice Requires="p14">
       <p:transition spd="slow" p14:dur="1500">
         <p:split orient="vert"/>
       </p:transition>
     </mc:Choice>
-    <mc:Fallback>
+    <mc:Fallback xmlns="">
       <p:transition spd="slow">
         <p:split orient="vert"/>
       </p:transition>

</xml_diff>